<commit_message>
Proofread facts-grounding slides page by page with Gemini
</commit_message>
<xml_diff>
--- a/slides/datasets-in-10-minutes-facts-grounding.pptx
+++ b/slides/datasets-in-10-minutes-facts-grounding.pptx
@@ -9000,7 +9000,7 @@
                 <a:ea typeface="Noto Sans CJK JP"/>
                 <a:cs typeface="Noto Sans"/>
               </a:rPr>
-              <a:t>さらに、依頼へ十分に応えた回答かを判定する。依頼を満たさない回答は、根拠のある内容だけでも0点として集計する。</a:t>
+              <a:t>さらに、依頼へ十分に応えた回答かを判定する。依頼を満たさない回答は、根拠のある内容だけであっても0点として集計する。</a:t>
             </a:r>
           </a:p>
           <a:p>
@@ -11757,7 +11757,7 @@
                 <a:ea typeface="Noto Sans CJK JP"/>
                 <a:cs typeface="Noto Sans"/>
               </a:rPr>
-              <a:t>Groundingと、4課題の総合得点の関係</a:t>
+              <a:t>Groundingと4課題の総合得点の関係</a:t>
             </a:r>
           </a:p>
         </p:txBody>
@@ -12481,7 +12481,7 @@
         </p:nvGraphicFramePr>
         <p:xfrm>
           <a:off x="548640" y="1508760"/>
-          <a:ext cx="8046720" cy="2743200"/>
+          <a:ext cx="8046720" cy="3048000"/>
         </p:xfrm>
         <a:graphic>
           <a:graphicData uri="http://schemas.openxmlformats.org/drawingml/2006/table">
@@ -12946,7 +12946,7 @@
                           <a:ea typeface="Noto Sans CJK JP"/>
                           <a:cs typeface="Noto Sans"/>
                         </a:rPr>
-                        <a:t>全件を確認</a:t>
+                        <a:t>全件を確認する</a:t>
                       </a:r>
                     </a:p>
                   </a:txBody>
@@ -12996,7 +12996,7 @@
                           <a:ea typeface="Noto Sans CJK JP"/>
                           <a:cs typeface="Noto Sans"/>
                         </a:rPr>
-                        <a:t>指示との整合と文書の可読性を人が点検</a:t>
+                        <a:t>指示との整合性と文書の可読性を人が点検する</a:t>
                       </a:r>
                     </a:p>
                   </a:txBody>
@@ -13019,7 +13019,7 @@
                   </a:tcPr>
                 </a:tc>
               </a:tr>
-              <a:tr h="457200">
+              <a:tr h="762000">
                 <a:tc>
                   <a:txBody>
                     <a:bodyPr wrap="square">
@@ -13101,7 +13101,7 @@
                           <a:ea typeface="Noto Sans CJK JP"/>
                           <a:cs typeface="Noto Sans"/>
                         </a:rPr>
-                        <a:t>バランスを取った無作為抽出で公開・非公開へ</a:t>
+                        <a:t>バランスを取った無作為抽出で公開・非公開に分割する</a:t>
                       </a:r>
                     </a:p>
                   </a:txBody>
@@ -13336,7 +13336,7 @@
                 <a:ea typeface="Noto Sans CJK JP"/>
                 <a:cs typeface="Noto Sans"/>
               </a:rPr>
-              <a:t>作成者には、長い文書を処理し、長い回答を書く依頼を求めた。専門知識、複雑な推論、文体や著者意図の分析を必要とする依頼は避ける。</a:t>
+              <a:t>作成者には、長い文書を処理し、長い回答を書く依頼を求めた。専門知識、複雑な推論、文体や著者意図の分析を必要とする依頼は避けた。</a:t>
             </a:r>
           </a:p>
           <a:p>
@@ -14682,7 +14682,7 @@
                           <a:ea typeface="Noto Sans CJK JP"/>
                           <a:cs typeface="Noto Sans"/>
                         </a:rPr>
-                        <a:t>事実を探す</a:t>
+                        <a:t>事実の抽出</a:t>
                       </a:r>
                     </a:p>
                   </a:txBody>
@@ -14790,7 +14790,7 @@
                           <a:ea typeface="Noto Sans CJK JP"/>
                           <a:cs typeface="Noto Sans"/>
                         </a:rPr>
-                        <a:t>探して要約する</a:t>
+                        <a:t>抽出して要約する</a:t>
                       </a:r>
                     </a:p>
                   </a:txBody>
@@ -15498,7 +15498,7 @@
                 <a:ea typeface="Noto Sans CJK JP"/>
                 <a:cs typeface="Noto Sans"/>
               </a:rPr>
-              <a:t>2024年12月に、文書に基づく回答を扱うFACTS Groundingを公開。公開860問と非公開859問で評価を運営する。</a:t>
+              <a:t>2024年12月に、文書に基づく回答を扱うFACTS Groundingを公開。公開860問と非公開859問で評価を実施する。</a:t>
             </a:r>
           </a:p>
           <a:p>
@@ -16364,7 +16364,7 @@
                 <a:ea typeface="Noto Sans CJK JP"/>
                 <a:cs typeface="Noto Sans"/>
               </a:rPr>
-              <a:t>FACTS Groundingは、文書の情報を使い、依頼へ応える文章を生成する評価。質問応答だけでなく要約・比較・書き換えも含む。</a:t>
+              <a:t>FACTS Groundingは、文書の情報を使い、依頼に応える文章を生成する評価。質問応答だけでなく要約・比較・書き換えも含む。</a:t>
             </a:r>
           </a:p>
           <a:p>
@@ -16394,7 +16394,7 @@
                 <a:ea typeface="Noto Sans CJK JP"/>
                 <a:cs typeface="Noto Sans"/>
               </a:rPr>
-              <a:t>v2は入力問題を保ち、判定モデルと採点指示を更新した。事実性に加え、依頼へ十分に応えることを得点に反映する。</a:t>
+              <a:t>v2は入力問題を維持し、判定モデルと採点指示を更新した。事実性に加え、依頼に十分応えることを得点に反映する。</a:t>
             </a:r>
           </a:p>
           <a:p>
@@ -19734,7 +19734,7 @@
                 <a:ea typeface="Noto Sans CJK JP"/>
                 <a:cs typeface="Noto Sans"/>
               </a:rPr>
-              <a:t>ガンマ線望遠鏡と赤外線望遠鏡の違いを説明する。</a:t>
+              <a:t>ガンマ線望遠鏡と赤外線望遠鏡の違いを説明せよ。</a:t>
             </a:r>
           </a:p>
         </p:txBody>
@@ -19842,7 +19842,7 @@
                 <a:ea typeface="Noto Sans CJK JP"/>
                 <a:cs typeface="Noto Sans"/>
               </a:rPr>
-              <a:t>ガンマ線望遠鏡はレンズや鏡を使わず検出する。赤外線望遠鏡は、塵に包まれた天体の観測などに使う。</a:t>
+              <a:t>ガンマ線望遠鏡はレンズや鏡を使わずに検出する。赤外線望遠鏡は、塵に包まれた天体の観測などに使う。</a:t>
             </a:r>
           </a:p>
         </p:txBody>
@@ -20620,7 +20620,7 @@
                 <a:ea typeface="Noto Sans CJK JP"/>
                 <a:cs typeface="Noto Sans"/>
               </a:rPr>
-              <a:t>慢性C型肝炎ウイルス（HCV）感染者のうち、感染を自覚している人の世界全体での割合は。</a:t>
+              <a:t>慢性C型肝炎ウイルス（HCV）感染者のうち、感染を自覚している人の世界全体での割合は何％か。</a:t>
             </a:r>
           </a:p>
         </p:txBody>
@@ -21620,7 +21620,7 @@
                 <a:ea typeface="Noto Sans CJK JP"/>
                 <a:cs typeface="Noto Sans"/>
               </a:rPr>
-              <a:t>パンフレットに掲載されたディズニーのテーマパーク名を挙げる。</a:t>
+              <a:t>パンフレットに掲載されているディズニーのテーマパークの名前は何か。</a:t>
             </a:r>
           </a:p>
         </p:txBody>
@@ -22506,7 +22506,7 @@
                 <a:ea typeface="Noto Sans CJK JP"/>
                 <a:cs typeface="Noto Sans"/>
               </a:rPr>
-              <a:t>無線インターネット事業者（WISP）の接続に問題を起こす地形は。</a:t>
+              <a:t>無線インターネット事業者（WISP）の接続に問題を引き起こす地形は何か。</a:t>
             </a:r>
           </a:p>
         </p:txBody>
@@ -23392,7 +23392,7 @@
                 <a:ea typeface="Noto Sans CJK JP"/>
                 <a:cs typeface="Noto Sans"/>
               </a:rPr>
-              <a:t>利用できるファイアウォールと、その動作を説明する。</a:t>
+              <a:t>利用できるファイアウォールと、その動作を説明してください。</a:t>
             </a:r>
           </a:p>
         </p:txBody>
@@ -24278,7 +24278,7 @@
                 <a:ea typeface="Noto Sans CJK JP"/>
                 <a:cs typeface="Noto Sans"/>
               </a:rPr>
-              <a:t>FEMA経由と比べ、Wi-Fiや携帯網で地震速報を送る利点は。</a:t>
+              <a:t>FEMA経由と比べ、Wi-Fiや携帯網で地震速報を送る利点は何か。</a:t>
             </a:r>
           </a:p>
         </p:txBody>
@@ -25786,7 +25786,7 @@
                 <a:ea typeface="Noto Sans CJK JP"/>
                 <a:cs typeface="Noto Sans"/>
               </a:rPr>
-              <a:t>与えられた文書だけを根拠に、依頼へ答える</a:t>
+              <a:t>与えられた文書だけを根拠に、依頼に応える</a:t>
             </a:r>
           </a:p>
         </p:txBody>
@@ -25839,7 +25839,7 @@
                 <a:ea typeface="Noto Sans CJK JP"/>
                 <a:cs typeface="Noto Sans"/>
               </a:rPr>
-              <a:t>FACTS Groundingは、文書と依頼を読み、文書に基づく回答を生成する評価。質問応答、要約、比較、書き換えなどを扱う。</a:t>
+              <a:t>FACTS Groundingは、文書と依頼を読み、文書に基づく回答を生成する能力を評価する。質問応答、要約、比較、書き換えなどを扱う。</a:t>
             </a:r>
           </a:p>
           <a:p>
@@ -25899,7 +25899,7 @@
                 <a:ea typeface="Noto Sans CJK JP"/>
                 <a:cs typeface="Noto Sans"/>
               </a:rPr>
-              <a:t>採点では、回答が依頼に応えているかと、回答中の主張が文書に支えられているかを調べる。</a:t>
+              <a:t>採点では、回答が依頼に応えているかと、回答中の主張が文書に裏付けられているかを調べる。</a:t>
             </a:r>
           </a:p>
         </p:txBody>
@@ -27828,7 +27828,7 @@
                 <a:ea typeface="Noto Sans CJK JP"/>
                 <a:cs typeface="Noto Sans"/>
               </a:rPr>
-              <a:t>依頼の残りの種類と、構成比</a:t>
+              <a:t>依頼の残りの種類と構成比</a:t>
             </a:r>
           </a:p>
         </p:txBody>
@@ -28909,7 +28909,7 @@
                 <a:ea typeface="Noto Sans CJK JP"/>
                 <a:cs typeface="Noto Sans"/>
               </a:rPr>
-              <a:t>配布する入力と、バージョン別の評価資料</a:t>
+              <a:t>配布されている入力と、バージョン別の評価資料</a:t>
             </a:r>
           </a:p>
         </p:txBody>
@@ -28962,7 +28962,7 @@
                 <a:ea typeface="Noto Sans CJK JP"/>
                 <a:cs typeface="Noto Sans"/>
               </a:rPr>
-              <a:t>データはGoogleのHugging Face配布から、examples.csvを取得する。ライセンスはCC BY 4.0。転載した文書・依頼と訳には出典を付した。</a:t>
+              <a:t>データはGoogleのHugging Face配布から、examples.csvを取得した。ライセンスはCC BY 4.0。転載した文書・依頼と訳には出典を付した。</a:t>
             </a:r>
           </a:p>
           <a:p>
@@ -28992,7 +28992,7 @@
                 <a:ea typeface="Noto Sans CJK JP"/>
                 <a:cs typeface="Noto Sans"/>
               </a:rPr>
-              <a:t>同じ配布にあるevaluation_prompts.csvは、2024年の初期評価の採点指示。v2の判定モデル・指示の変更は、2025年のスイート論文で確認する。</a:t>
+              <a:t>同じ配布にあるevaluation_prompts.csvは、2024年の初期評価の採点指示。v2の判定モデル・指示の変更は、2025年のスイート論文で確認できる。</a:t>
             </a:r>
           </a:p>
           <a:p>
@@ -30126,7 +30126,7 @@
                 <a:ea typeface="Noto Sans CJK JP"/>
                 <a:cs typeface="Noto Sans"/>
               </a:rPr>
-              <a:t>人名や年を一つ答える評価に対し、この課題は複数の主張を含む回答を対象にする。文書の情報を選び、まとめて依頼へ応える。</a:t>
+              <a:t>人名や年を一つ答える評価に対し、この課題は複数の主張を含む回答を対象にする。文書の情報を選び、まとめて依頼に応える。</a:t>
             </a:r>
           </a:p>
           <a:p>

</xml_diff>